<commit_message>
Edited chart styling and updates results
</commit_message>
<xml_diff>
--- a/results/presentation.pptx
+++ b/results/presentation.pptx
@@ -273,14 +273,69 @@
       </c:catAx>
       <c:valAx>
         <c:axId val="-2113994440"/>
-        <c:scaling/>
-        <c:delete/>
+        <c:scaling>
+          <c:max val="100.0"/>
+          <c:min val="0.0"/>
+        </c:scaling>
+        <c:delete val="0"/>
         <c:axPos val="b"/>
+        <c:majorGridlines>
+          <c:spPr>
+            <a:ln w="3175">
+              <a:solidFill>
+                <a:srgbClr val="E5E7EB"/>
+              </a:solidFill>
+            </a:ln>
+          </c:spPr>
+        </c:majorGridlines>
+        <c:title>
+          <c:tx>
+            <c:rich>
+              <a:bodyPr/>
+              <a:lstStyle/>
+              <a:p>
+                <a:pPr>
+                  <a:defRPr sz="1100" b="0">
+                    <a:solidFill>
+                      <a:srgbClr val="6B7280"/>
+                    </a:solidFill>
+                    <a:latin typeface="Calibri"/>
+                  </a:defRPr>
+                </a:pPr>
+                <a:r>
+                  <a:t>%</a:t>
+                </a:r>
+              </a:p>
+            </c:rich>
+          </c:tx>
+          <c:layout/>
+          <c:overlay val="0"/>
+        </c:title>
         <c:majorTickMark val="out"/>
         <c:minorTickMark val="none"/>
         <c:tickLblPos val="nextTo"/>
+        <c:spPr>
+          <a:ln>
+            <a:noFill/>
+          </a:ln>
+        </c:spPr>
+        <c:txPr>
+          <a:bodyPr/>
+          <a:lstStyle/>
+          <a:p>
+            <a:pPr>
+              <a:defRPr sz="1100">
+                <a:solidFill>
+                  <a:srgbClr val="6B7280"/>
+                </a:solidFill>
+                <a:latin typeface="Calibri"/>
+              </a:defRPr>
+            </a:pPr>
+          </a:p>
+        </c:txPr>
         <c:crossAx val="-2068027336"/>
         <c:crosses val="autoZero"/>
+        <c:majorUnit val="25.0"/>
       </c:valAx>
     </c:plotArea>
     <c:dispBlanksAs val="gap"/>
@@ -477,14 +532,69 @@
       </c:catAx>
       <c:valAx>
         <c:axId val="-2113994440"/>
-        <c:scaling/>
-        <c:delete/>
+        <c:scaling>
+          <c:max val="100.0"/>
+          <c:min val="0.0"/>
+        </c:scaling>
+        <c:delete val="0"/>
         <c:axPos val="b"/>
+        <c:majorGridlines>
+          <c:spPr>
+            <a:ln w="3175">
+              <a:solidFill>
+                <a:srgbClr val="E5E7EB"/>
+              </a:solidFill>
+            </a:ln>
+          </c:spPr>
+        </c:majorGridlines>
+        <c:title>
+          <c:tx>
+            <c:rich>
+              <a:bodyPr/>
+              <a:lstStyle/>
+              <a:p>
+                <a:pPr>
+                  <a:defRPr sz="1100" b="0">
+                    <a:solidFill>
+                      <a:srgbClr val="6B7280"/>
+                    </a:solidFill>
+                    <a:latin typeface="Calibri"/>
+                  </a:defRPr>
+                </a:pPr>
+                <a:r>
+                  <a:t>%</a:t>
+                </a:r>
+              </a:p>
+            </c:rich>
+          </c:tx>
+          <c:layout/>
+          <c:overlay val="0"/>
+        </c:title>
         <c:majorTickMark val="out"/>
         <c:minorTickMark val="none"/>
         <c:tickLblPos val="nextTo"/>
+        <c:spPr>
+          <a:ln>
+            <a:noFill/>
+          </a:ln>
+        </c:spPr>
+        <c:txPr>
+          <a:bodyPr/>
+          <a:lstStyle/>
+          <a:p>
+            <a:pPr>
+              <a:defRPr sz="1100">
+                <a:solidFill>
+                  <a:srgbClr val="6B7280"/>
+                </a:solidFill>
+                <a:latin typeface="Calibri"/>
+              </a:defRPr>
+            </a:pPr>
+          </a:p>
+        </c:txPr>
         <c:crossAx val="-2068027336"/>
         <c:crosses val="autoZero"/>
+        <c:majorUnit val="25.0"/>
       </c:valAx>
     </c:plotArea>
     <c:dispBlanksAs val="gap"/>
@@ -751,14 +861,69 @@
       </c:catAx>
       <c:valAx>
         <c:axId val="-2113994440"/>
-        <c:scaling/>
-        <c:delete/>
+        <c:scaling>
+          <c:max val="100.0"/>
+          <c:min val="0.0"/>
+        </c:scaling>
+        <c:delete val="0"/>
         <c:axPos val="b"/>
+        <c:majorGridlines>
+          <c:spPr>
+            <a:ln w="3175">
+              <a:solidFill>
+                <a:srgbClr val="E5E7EB"/>
+              </a:solidFill>
+            </a:ln>
+          </c:spPr>
+        </c:majorGridlines>
+        <c:title>
+          <c:tx>
+            <c:rich>
+              <a:bodyPr/>
+              <a:lstStyle/>
+              <a:p>
+                <a:pPr>
+                  <a:defRPr sz="1100" b="0">
+                    <a:solidFill>
+                      <a:srgbClr val="6B7280"/>
+                    </a:solidFill>
+                    <a:latin typeface="Calibri"/>
+                  </a:defRPr>
+                </a:pPr>
+                <a:r>
+                  <a:t>%</a:t>
+                </a:r>
+              </a:p>
+            </c:rich>
+          </c:tx>
+          <c:layout/>
+          <c:overlay val="0"/>
+        </c:title>
         <c:majorTickMark val="out"/>
         <c:minorTickMark val="none"/>
         <c:tickLblPos val="nextTo"/>
+        <c:spPr>
+          <a:ln>
+            <a:noFill/>
+          </a:ln>
+        </c:spPr>
+        <c:txPr>
+          <a:bodyPr/>
+          <a:lstStyle/>
+          <a:p>
+            <a:pPr>
+              <a:defRPr sz="1100">
+                <a:solidFill>
+                  <a:srgbClr val="6B7280"/>
+                </a:solidFill>
+                <a:latin typeface="Calibri"/>
+              </a:defRPr>
+            </a:pPr>
+          </a:p>
+        </c:txPr>
         <c:crossAx val="-2068027336"/>
         <c:crosses val="autoZero"/>
+        <c:majorUnit val="25.0"/>
       </c:valAx>
     </c:plotArea>
     <c:dispBlanksAs val="gap"/>

</xml_diff>